<commit_message>
Update annotations.pptx and magicmirror_annotated.png in assets folder
</commit_message>
<xml_diff>
--- a/assets/docs/annotations.pptx
+++ b/assets/docs/annotations.pptx
@@ -7,6 +7,7 @@
   <p:sldIdLst>
     <p:sldId id="256" r:id="rId2"/>
     <p:sldId id="257" r:id="rId3"/>
+    <p:sldId id="258" r:id="rId4"/>
   </p:sldIdLst>
   <p:sldSz cx="12192000" cy="6858000"/>
   <p:notesSz cx="6858000" cy="9144000"/>
@@ -105,6 +106,11 @@
       </a:defRPr>
     </a:lvl9pPr>
   </p:defaultTextStyle>
+  <p:extLst>
+    <p:ext uri="{EFAFB233-063F-42B5-8137-9DF3F51BA10A}">
+      <p15:sldGuideLst xmlns:p15="http://schemas.microsoft.com/office/powerpoint/2012/main"/>
+    </p:ext>
+  </p:extLst>
 </p:presentation>
 </file>
 
@@ -3443,8 +3449,18 @@
                 <a:solidFill>
                   <a:srgbClr val="FAFAFA"/>
                 </a:solidFill>
+                <a:latin typeface="Roboto" panose="02000000000000000000" pitchFamily="2" charset="0"/>
+                <a:ea typeface="Roboto" panose="02000000000000000000" pitchFamily="2" charset="0"/>
               </a:rPr>
-              <a:t>Raspberry Pi</a:t>
+              <a:t>Raspberry</a:t>
+            </a:r>
+            <a:r>
+              <a:rPr lang="en-US" dirty="0">
+                <a:solidFill>
+                  <a:srgbClr val="FAFAFA"/>
+                </a:solidFill>
+              </a:rPr>
+              <a:t> Pi</a:t>
             </a:r>
           </a:p>
         </p:txBody>
@@ -3504,6 +3520,8 @@
                 <a:solidFill>
                   <a:srgbClr val="FAFAFA"/>
                 </a:solidFill>
+                <a:latin typeface="Roboto" panose="02000000000000000000" pitchFamily="2" charset="0"/>
+                <a:ea typeface="Roboto" panose="02000000000000000000" pitchFamily="2" charset="0"/>
               </a:rPr>
               <a:t>Frame</a:t>
             </a:r>
@@ -3565,8 +3583,19 @@
                 <a:solidFill>
                   <a:srgbClr val="FAFAFA"/>
                 </a:solidFill>
+                <a:latin typeface="Roboto" panose="02000000000000000000" pitchFamily="2" charset="0"/>
+                <a:ea typeface="Roboto" panose="02000000000000000000" pitchFamily="2" charset="0"/>
+                <a:cs typeface="Roboto" panose="020F0502020204030204" pitchFamily="2" charset="0"/>
               </a:rPr>
-              <a:t>Monitor PCBs</a:t>
+              <a:t>Monitor</a:t>
+            </a:r>
+            <a:r>
+              <a:rPr lang="en-US" dirty="0">
+                <a:solidFill>
+                  <a:srgbClr val="FAFAFA"/>
+                </a:solidFill>
+              </a:rPr>
+              <a:t> PCBs</a:t>
             </a:r>
           </a:p>
         </p:txBody>
@@ -3806,6 +3835,8 @@
                 <a:solidFill>
                   <a:srgbClr val="FAFAFA"/>
                 </a:solidFill>
+                <a:latin typeface="Roboto" panose="02000000000000000000" pitchFamily="2" charset="0"/>
+                <a:ea typeface="Roboto" panose="02000000000000000000" pitchFamily="2" charset="0"/>
               </a:rPr>
               <a:t>DC-DC Step Down to 5V</a:t>
             </a:r>
@@ -3861,6 +3892,72 @@
     <p:extLst>
       <p:ext uri="{BB962C8B-B14F-4D97-AF65-F5344CB8AC3E}">
         <p14:creationId xmlns:p14="http://schemas.microsoft.com/office/powerpoint/2010/main" val="3484042181"/>
+      </p:ext>
+    </p:extLst>
+  </p:cSld>
+  <p:clrMapOvr>
+    <a:masterClrMapping/>
+  </p:clrMapOvr>
+</p:sld>
+</file>
+
+<file path=ppt/slides/slide3.xml><?xml version="1.0" encoding="utf-8"?>
+<p:sld xmlns:a="http://schemas.openxmlformats.org/drawingml/2006/main" xmlns:r="http://schemas.openxmlformats.org/officeDocument/2006/relationships" xmlns:p="http://schemas.openxmlformats.org/presentationml/2006/main">
+  <p:cSld>
+    <p:spTree>
+      <p:nvGrpSpPr>
+        <p:cNvPr id="1" name=""/>
+        <p:cNvGrpSpPr/>
+        <p:nvPr/>
+      </p:nvGrpSpPr>
+      <p:grpSpPr>
+        <a:xfrm>
+          <a:off x="0" y="0"/>
+          <a:ext cx="0" cy="0"/>
+          <a:chOff x="0" y="0"/>
+          <a:chExt cx="0" cy="0"/>
+        </a:xfrm>
+      </p:grpSpPr>
+      <p:pic>
+        <p:nvPicPr>
+          <p:cNvPr id="5" name="Picture 4">
+            <a:extLst>
+              <a:ext uri="{FF2B5EF4-FFF2-40B4-BE49-F238E27FC236}">
+                <a16:creationId xmlns:a16="http://schemas.microsoft.com/office/drawing/2014/main" id="{7609AD2B-F16E-906C-E76A-7DD53C789B2E}"/>
+              </a:ext>
+            </a:extLst>
+          </p:cNvPr>
+          <p:cNvPicPr>
+            <a:picLocks noChangeAspect="1"/>
+          </p:cNvPicPr>
+          <p:nvPr/>
+        </p:nvPicPr>
+        <p:blipFill>
+          <a:blip r:embed="rId2">
+            <a:extLst>
+              <a:ext uri="{28A0092B-C50C-407E-A947-70E740481C1C}">
+                <a14:useLocalDpi xmlns:a14="http://schemas.microsoft.com/office/drawing/2010/main" val="0"/>
+              </a:ext>
+            </a:extLst>
+          </a:blip>
+          <a:stretch>
+            <a:fillRect/>
+          </a:stretch>
+        </p:blipFill>
+        <p:spPr>
+          <a:xfrm>
+            <a:off x="0" y="-6095"/>
+            <a:ext cx="12192000" cy="6864096"/>
+          </a:xfrm>
+          <a:prstGeom prst="rect">
+            <a:avLst/>
+          </a:prstGeom>
+        </p:spPr>
+      </p:pic>
+    </p:spTree>
+    <p:extLst>
+      <p:ext uri="{BB962C8B-B14F-4D97-AF65-F5344CB8AC3E}">
+        <p14:creationId xmlns:p14="http://schemas.microsoft.com/office/powerpoint/2010/main" val="2462977862"/>
       </p:ext>
     </p:extLst>
   </p:cSld>

</xml_diff>

<commit_message>
moved ggTrade.md to drafts and updated annotations.pptx
</commit_message>
<xml_diff>
--- a/assets/docs/annotations.pptx
+++ b/assets/docs/annotations.pptx
@@ -7,7 +7,9 @@
   <p:sldIdLst>
     <p:sldId id="256" r:id="rId2"/>
     <p:sldId id="257" r:id="rId3"/>
-    <p:sldId id="258" r:id="rId4"/>
+    <p:sldId id="259" r:id="rId4"/>
+    <p:sldId id="260" r:id="rId5"/>
+    <p:sldId id="258" r:id="rId6"/>
   </p:sldIdLst>
   <p:sldSz cx="12192000" cy="6858000"/>
   <p:notesSz cx="6858000" cy="9144000"/>
@@ -108,7 +110,18 @@
   </p:defaultTextStyle>
   <p:extLst>
     <p:ext uri="{EFAFB233-063F-42B5-8137-9DF3F51BA10A}">
-      <p15:sldGuideLst xmlns:p15="http://schemas.microsoft.com/office/powerpoint/2012/main"/>
+      <p15:sldGuideLst xmlns:p15="http://schemas.microsoft.com/office/powerpoint/2012/main">
+        <p15:guide id="1" orient="horz" pos="2160" userDrawn="1">
+          <p15:clr>
+            <a:srgbClr val="A4A3A4"/>
+          </p15:clr>
+        </p15:guide>
+        <p15:guide id="2" pos="3840" userDrawn="1">
+          <p15:clr>
+            <a:srgbClr val="A4A3A4"/>
+          </p15:clr>
+        </p15:guide>
+      </p15:sldGuideLst>
     </p:ext>
   </p:extLst>
 </p:presentation>
@@ -261,7 +274,7 @@
           <a:p>
             <a:fld id="{4432FAB2-DE20-4F88-88E1-6FF07B33CC0B}" type="datetimeFigureOut">
               <a:rPr lang="en-US" smtClean="0"/>
-              <a:t>7/17/2025</a:t>
+              <a:t>7/18/2025</a:t>
             </a:fld>
             <a:endParaRPr lang="en-US"/>
           </a:p>
@@ -459,7 +472,7 @@
           <a:p>
             <a:fld id="{4432FAB2-DE20-4F88-88E1-6FF07B33CC0B}" type="datetimeFigureOut">
               <a:rPr lang="en-US" smtClean="0"/>
-              <a:t>7/17/2025</a:t>
+              <a:t>7/18/2025</a:t>
             </a:fld>
             <a:endParaRPr lang="en-US"/>
           </a:p>
@@ -667,7 +680,7 @@
           <a:p>
             <a:fld id="{4432FAB2-DE20-4F88-88E1-6FF07B33CC0B}" type="datetimeFigureOut">
               <a:rPr lang="en-US" smtClean="0"/>
-              <a:t>7/17/2025</a:t>
+              <a:t>7/18/2025</a:t>
             </a:fld>
             <a:endParaRPr lang="en-US"/>
           </a:p>
@@ -865,7 +878,7 @@
           <a:p>
             <a:fld id="{4432FAB2-DE20-4F88-88E1-6FF07B33CC0B}" type="datetimeFigureOut">
               <a:rPr lang="en-US" smtClean="0"/>
-              <a:t>7/17/2025</a:t>
+              <a:t>7/18/2025</a:t>
             </a:fld>
             <a:endParaRPr lang="en-US"/>
           </a:p>
@@ -1140,7 +1153,7 @@
           <a:p>
             <a:fld id="{4432FAB2-DE20-4F88-88E1-6FF07B33CC0B}" type="datetimeFigureOut">
               <a:rPr lang="en-US" smtClean="0"/>
-              <a:t>7/17/2025</a:t>
+              <a:t>7/18/2025</a:t>
             </a:fld>
             <a:endParaRPr lang="en-US"/>
           </a:p>
@@ -1405,7 +1418,7 @@
           <a:p>
             <a:fld id="{4432FAB2-DE20-4F88-88E1-6FF07B33CC0B}" type="datetimeFigureOut">
               <a:rPr lang="en-US" smtClean="0"/>
-              <a:t>7/17/2025</a:t>
+              <a:t>7/18/2025</a:t>
             </a:fld>
             <a:endParaRPr lang="en-US"/>
           </a:p>
@@ -1817,7 +1830,7 @@
           <a:p>
             <a:fld id="{4432FAB2-DE20-4F88-88E1-6FF07B33CC0B}" type="datetimeFigureOut">
               <a:rPr lang="en-US" smtClean="0"/>
-              <a:t>7/17/2025</a:t>
+              <a:t>7/18/2025</a:t>
             </a:fld>
             <a:endParaRPr lang="en-US"/>
           </a:p>
@@ -1958,7 +1971,7 @@
           <a:p>
             <a:fld id="{4432FAB2-DE20-4F88-88E1-6FF07B33CC0B}" type="datetimeFigureOut">
               <a:rPr lang="en-US" smtClean="0"/>
-              <a:t>7/17/2025</a:t>
+              <a:t>7/18/2025</a:t>
             </a:fld>
             <a:endParaRPr lang="en-US"/>
           </a:p>
@@ -2071,7 +2084,7 @@
           <a:p>
             <a:fld id="{4432FAB2-DE20-4F88-88E1-6FF07B33CC0B}" type="datetimeFigureOut">
               <a:rPr lang="en-US" smtClean="0"/>
-              <a:t>7/17/2025</a:t>
+              <a:t>7/18/2025</a:t>
             </a:fld>
             <a:endParaRPr lang="en-US"/>
           </a:p>
@@ -2382,7 +2395,7 @@
           <a:p>
             <a:fld id="{4432FAB2-DE20-4F88-88E1-6FF07B33CC0B}" type="datetimeFigureOut">
               <a:rPr lang="en-US" smtClean="0"/>
-              <a:t>7/17/2025</a:t>
+              <a:t>7/18/2025</a:t>
             </a:fld>
             <a:endParaRPr lang="en-US"/>
           </a:p>
@@ -2670,7 +2683,7 @@
           <a:p>
             <a:fld id="{4432FAB2-DE20-4F88-88E1-6FF07B33CC0B}" type="datetimeFigureOut">
               <a:rPr lang="en-US" smtClean="0"/>
-              <a:t>7/17/2025</a:t>
+              <a:t>7/18/2025</a:t>
             </a:fld>
             <a:endParaRPr lang="en-US"/>
           </a:p>
@@ -2911,7 +2924,7 @@
           <a:p>
             <a:fld id="{4432FAB2-DE20-4F88-88E1-6FF07B33CC0B}" type="datetimeFigureOut">
               <a:rPr lang="en-US" smtClean="0"/>
-              <a:t>7/17/2025</a:t>
+              <a:t>7/18/2025</a:t>
             </a:fld>
             <a:endParaRPr lang="en-US"/>
           </a:p>
@@ -3904,6 +3917,1612 @@
 <file path=ppt/slides/slide3.xml><?xml version="1.0" encoding="utf-8"?>
 <p:sld xmlns:a="http://schemas.openxmlformats.org/drawingml/2006/main" xmlns:r="http://schemas.openxmlformats.org/officeDocument/2006/relationships" xmlns:p="http://schemas.openxmlformats.org/presentationml/2006/main">
   <p:cSld>
+    <p:bg>
+      <p:bgPr>
+        <a:solidFill>
+          <a:srgbClr val="141818"/>
+        </a:solidFill>
+        <a:effectLst/>
+      </p:bgPr>
+    </p:bg>
+    <p:spTree>
+      <p:nvGrpSpPr>
+        <p:cNvPr id="1" name=""/>
+        <p:cNvGrpSpPr/>
+        <p:nvPr/>
+      </p:nvGrpSpPr>
+      <p:grpSpPr>
+        <a:xfrm>
+          <a:off x="0" y="0"/>
+          <a:ext cx="0" cy="0"/>
+          <a:chOff x="0" y="0"/>
+          <a:chExt cx="0" cy="0"/>
+        </a:xfrm>
+      </p:grpSpPr>
+      <p:sp>
+        <p:nvSpPr>
+          <p:cNvPr id="4" name="TextBox 3">
+            <a:extLst>
+              <a:ext uri="{FF2B5EF4-FFF2-40B4-BE49-F238E27FC236}">
+                <a16:creationId xmlns:a16="http://schemas.microsoft.com/office/drawing/2014/main" id="{2BC7E475-110F-4A3E-D26A-DDC34B734C41}"/>
+              </a:ext>
+            </a:extLst>
+          </p:cNvPr>
+          <p:cNvSpPr txBox="1"/>
+          <p:nvPr/>
+        </p:nvSpPr>
+        <p:spPr>
+          <a:xfrm>
+            <a:off x="1244403" y="1414989"/>
+            <a:ext cx="1627632" cy="715089"/>
+          </a:xfrm>
+          <a:prstGeom prst="roundRect">
+            <a:avLst/>
+          </a:prstGeom>
+          <a:solidFill>
+            <a:srgbClr val="141818"/>
+          </a:solidFill>
+          <a:ln w="28575">
+            <a:solidFill>
+              <a:srgbClr val="64D5D2"/>
+            </a:solidFill>
+          </a:ln>
+        </p:spPr>
+        <p:style>
+          <a:lnRef idx="2">
+            <a:schemeClr val="accent5"/>
+          </a:lnRef>
+          <a:fillRef idx="1">
+            <a:schemeClr val="lt1"/>
+          </a:fillRef>
+          <a:effectRef idx="0">
+            <a:schemeClr val="accent5"/>
+          </a:effectRef>
+          <a:fontRef idx="minor">
+            <a:schemeClr val="dk1"/>
+          </a:fontRef>
+        </p:style>
+        <p:txBody>
+          <a:bodyPr wrap="square" rtlCol="0" anchor="ctr">
+            <a:spAutoFit/>
+          </a:bodyPr>
+          <a:lstStyle/>
+          <a:p>
+            <a:pPr algn="ctr"/>
+            <a:r>
+              <a:rPr lang="en-US" dirty="0">
+                <a:solidFill>
+                  <a:srgbClr val="FAFAFA"/>
+                </a:solidFill>
+                <a:latin typeface="Roboto" panose="02000000000000000000" pitchFamily="2" charset="0"/>
+                <a:ea typeface="Roboto" panose="02000000000000000000" pitchFamily="2" charset="0"/>
+              </a:rPr>
+              <a:t>DC-DC Step Down to 5V</a:t>
+            </a:r>
+          </a:p>
+        </p:txBody>
+      </p:sp>
+      <p:sp>
+        <p:nvSpPr>
+          <p:cNvPr id="5" name="TextBox 4">
+            <a:extLst>
+              <a:ext uri="{FF2B5EF4-FFF2-40B4-BE49-F238E27FC236}">
+                <a16:creationId xmlns:a16="http://schemas.microsoft.com/office/drawing/2014/main" id="{D179D735-6667-0598-8AE4-401BE0150605}"/>
+              </a:ext>
+            </a:extLst>
+          </p:cNvPr>
+          <p:cNvSpPr txBox="1"/>
+          <p:nvPr/>
+        </p:nvSpPr>
+        <p:spPr>
+          <a:xfrm>
+            <a:off x="3911692" y="329258"/>
+            <a:ext cx="3517808" cy="408623"/>
+          </a:xfrm>
+          <a:prstGeom prst="roundRect">
+            <a:avLst/>
+          </a:prstGeom>
+          <a:solidFill>
+            <a:srgbClr val="141818"/>
+          </a:solidFill>
+          <a:ln w="28575">
+            <a:solidFill>
+              <a:srgbClr val="64D5D2"/>
+            </a:solidFill>
+          </a:ln>
+        </p:spPr>
+        <p:style>
+          <a:lnRef idx="2">
+            <a:schemeClr val="accent5"/>
+          </a:lnRef>
+          <a:fillRef idx="1">
+            <a:schemeClr val="lt1"/>
+          </a:fillRef>
+          <a:effectRef idx="0">
+            <a:schemeClr val="accent5"/>
+          </a:effectRef>
+          <a:fontRef idx="minor">
+            <a:schemeClr val="dk1"/>
+          </a:fontRef>
+        </p:style>
+        <p:txBody>
+          <a:bodyPr wrap="square" rtlCol="0" anchor="ctr">
+            <a:spAutoFit/>
+          </a:bodyPr>
+          <a:lstStyle/>
+          <a:p>
+            <a:pPr algn="ctr"/>
+            <a:r>
+              <a:rPr lang="en-US" dirty="0">
+                <a:solidFill>
+                  <a:srgbClr val="FAFAFA"/>
+                </a:solidFill>
+                <a:latin typeface="Roboto" panose="02000000000000000000" pitchFamily="2" charset="0"/>
+                <a:ea typeface="Roboto" panose="02000000000000000000" pitchFamily="2" charset="0"/>
+              </a:rPr>
+              <a:t>Text Color #FAFAFA </a:t>
+            </a:r>
+          </a:p>
+        </p:txBody>
+      </p:sp>
+      <p:sp>
+        <p:nvSpPr>
+          <p:cNvPr id="6" name="TextBox 5">
+            <a:extLst>
+              <a:ext uri="{FF2B5EF4-FFF2-40B4-BE49-F238E27FC236}">
+                <a16:creationId xmlns:a16="http://schemas.microsoft.com/office/drawing/2014/main" id="{50840EFF-4AB4-49D4-E6D3-5AFA8BD93BB8}"/>
+              </a:ext>
+            </a:extLst>
+          </p:cNvPr>
+          <p:cNvSpPr txBox="1"/>
+          <p:nvPr/>
+        </p:nvSpPr>
+        <p:spPr>
+          <a:xfrm>
+            <a:off x="3911691" y="910283"/>
+            <a:ext cx="3517809" cy="408623"/>
+          </a:xfrm>
+          <a:prstGeom prst="roundRect">
+            <a:avLst/>
+          </a:prstGeom>
+          <a:solidFill>
+            <a:srgbClr val="141818"/>
+          </a:solidFill>
+          <a:ln w="28575">
+            <a:solidFill>
+              <a:srgbClr val="64D5D2"/>
+            </a:solidFill>
+          </a:ln>
+        </p:spPr>
+        <p:style>
+          <a:lnRef idx="2">
+            <a:schemeClr val="accent5"/>
+          </a:lnRef>
+          <a:fillRef idx="1">
+            <a:schemeClr val="lt1"/>
+          </a:fillRef>
+          <a:effectRef idx="0">
+            <a:schemeClr val="accent5"/>
+          </a:effectRef>
+          <a:fontRef idx="minor">
+            <a:schemeClr val="dk1"/>
+          </a:fontRef>
+        </p:style>
+        <p:txBody>
+          <a:bodyPr wrap="square" rtlCol="0" anchor="ctr">
+            <a:spAutoFit/>
+          </a:bodyPr>
+          <a:lstStyle/>
+          <a:p>
+            <a:pPr algn="ctr"/>
+            <a:r>
+              <a:rPr lang="en-US" dirty="0">
+                <a:solidFill>
+                  <a:srgbClr val="64D5D2"/>
+                </a:solidFill>
+                <a:latin typeface="Roboto" panose="02000000000000000000" pitchFamily="2" charset="0"/>
+                <a:ea typeface="Roboto" panose="02000000000000000000" pitchFamily="2" charset="0"/>
+              </a:rPr>
+              <a:t>Primary Accent #64D5D2</a:t>
+            </a:r>
+          </a:p>
+        </p:txBody>
+      </p:sp>
+      <p:sp>
+        <p:nvSpPr>
+          <p:cNvPr id="8" name="TextBox 7">
+            <a:extLst>
+              <a:ext uri="{FF2B5EF4-FFF2-40B4-BE49-F238E27FC236}">
+                <a16:creationId xmlns:a16="http://schemas.microsoft.com/office/drawing/2014/main" id="{1D22F96D-7CAE-FC1A-16E5-73BA72BC4F68}"/>
+              </a:ext>
+            </a:extLst>
+          </p:cNvPr>
+          <p:cNvSpPr txBox="1"/>
+          <p:nvPr/>
+        </p:nvSpPr>
+        <p:spPr>
+          <a:xfrm>
+            <a:off x="3911690" y="1510527"/>
+            <a:ext cx="3517810" cy="408623"/>
+          </a:xfrm>
+          <a:prstGeom prst="roundRect">
+            <a:avLst/>
+          </a:prstGeom>
+          <a:solidFill>
+            <a:srgbClr val="141818"/>
+          </a:solidFill>
+          <a:ln w="28575">
+            <a:solidFill>
+              <a:srgbClr val="64D5D2"/>
+            </a:solidFill>
+          </a:ln>
+        </p:spPr>
+        <p:style>
+          <a:lnRef idx="2">
+            <a:schemeClr val="accent5"/>
+          </a:lnRef>
+          <a:fillRef idx="1">
+            <a:schemeClr val="lt1"/>
+          </a:fillRef>
+          <a:effectRef idx="0">
+            <a:schemeClr val="accent5"/>
+          </a:effectRef>
+          <a:fontRef idx="minor">
+            <a:schemeClr val="dk1"/>
+          </a:fontRef>
+        </p:style>
+        <p:txBody>
+          <a:bodyPr wrap="square" rtlCol="0" anchor="ctr">
+            <a:spAutoFit/>
+          </a:bodyPr>
+          <a:lstStyle/>
+          <a:p>
+            <a:pPr algn="ctr"/>
+            <a:r>
+              <a:rPr lang="en-US" dirty="0">
+                <a:solidFill>
+                  <a:srgbClr val="2E4C5B"/>
+                </a:solidFill>
+                <a:latin typeface="Roboto" panose="02000000000000000000" pitchFamily="2" charset="0"/>
+                <a:ea typeface="Roboto" panose="02000000000000000000" pitchFamily="2" charset="0"/>
+              </a:rPr>
+              <a:t>Hover Background #2E4C5B</a:t>
+            </a:r>
+          </a:p>
+        </p:txBody>
+      </p:sp>
+      <p:sp>
+        <p:nvSpPr>
+          <p:cNvPr id="9" name="TextBox 8">
+            <a:extLst>
+              <a:ext uri="{FF2B5EF4-FFF2-40B4-BE49-F238E27FC236}">
+                <a16:creationId xmlns:a16="http://schemas.microsoft.com/office/drawing/2014/main" id="{199EC80E-2517-106C-3BD3-5F4B14C3A180}"/>
+              </a:ext>
+            </a:extLst>
+          </p:cNvPr>
+          <p:cNvSpPr txBox="1"/>
+          <p:nvPr/>
+        </p:nvSpPr>
+        <p:spPr>
+          <a:xfrm>
+            <a:off x="3911690" y="2130078"/>
+            <a:ext cx="3517810" cy="408623"/>
+          </a:xfrm>
+          <a:prstGeom prst="roundRect">
+            <a:avLst/>
+          </a:prstGeom>
+          <a:solidFill>
+            <a:srgbClr val="141818"/>
+          </a:solidFill>
+          <a:ln w="28575">
+            <a:solidFill>
+              <a:srgbClr val="64D5D2"/>
+            </a:solidFill>
+          </a:ln>
+        </p:spPr>
+        <p:style>
+          <a:lnRef idx="2">
+            <a:schemeClr val="accent5"/>
+          </a:lnRef>
+          <a:fillRef idx="1">
+            <a:schemeClr val="lt1"/>
+          </a:fillRef>
+          <a:effectRef idx="0">
+            <a:schemeClr val="accent5"/>
+          </a:effectRef>
+          <a:fontRef idx="minor">
+            <a:schemeClr val="dk1"/>
+          </a:fontRef>
+        </p:style>
+        <p:txBody>
+          <a:bodyPr wrap="square" rtlCol="0" anchor="ctr">
+            <a:spAutoFit/>
+          </a:bodyPr>
+          <a:lstStyle/>
+          <a:p>
+            <a:pPr algn="ctr"/>
+            <a:r>
+              <a:rPr lang="en-US" dirty="0">
+                <a:solidFill>
+                  <a:srgbClr val="5BC0DE"/>
+                </a:solidFill>
+                <a:latin typeface="Roboto" panose="02000000000000000000" pitchFamily="2" charset="0"/>
+                <a:ea typeface="Roboto" panose="02000000000000000000" pitchFamily="2" charset="0"/>
+              </a:rPr>
+              <a:t>Highlight Accent #5BC0DE</a:t>
+            </a:r>
+          </a:p>
+        </p:txBody>
+      </p:sp>
+      <p:sp>
+        <p:nvSpPr>
+          <p:cNvPr id="10" name="TextBox 9">
+            <a:extLst>
+              <a:ext uri="{FF2B5EF4-FFF2-40B4-BE49-F238E27FC236}">
+                <a16:creationId xmlns:a16="http://schemas.microsoft.com/office/drawing/2014/main" id="{2F44B4C5-F096-D945-76B0-99B3DF85F889}"/>
+              </a:ext>
+            </a:extLst>
+          </p:cNvPr>
+          <p:cNvSpPr txBox="1"/>
+          <p:nvPr/>
+        </p:nvSpPr>
+        <p:spPr>
+          <a:xfrm>
+            <a:off x="3911690" y="2759918"/>
+            <a:ext cx="3517810" cy="408623"/>
+          </a:xfrm>
+          <a:prstGeom prst="roundRect">
+            <a:avLst/>
+          </a:prstGeom>
+          <a:solidFill>
+            <a:srgbClr val="141818"/>
+          </a:solidFill>
+          <a:ln w="28575">
+            <a:solidFill>
+              <a:srgbClr val="64D5D2"/>
+            </a:solidFill>
+          </a:ln>
+        </p:spPr>
+        <p:style>
+          <a:lnRef idx="2">
+            <a:schemeClr val="accent5"/>
+          </a:lnRef>
+          <a:fillRef idx="1">
+            <a:schemeClr val="lt1"/>
+          </a:fillRef>
+          <a:effectRef idx="0">
+            <a:schemeClr val="accent5"/>
+          </a:effectRef>
+          <a:fontRef idx="minor">
+            <a:schemeClr val="dk1"/>
+          </a:fontRef>
+        </p:style>
+        <p:txBody>
+          <a:bodyPr wrap="square" rtlCol="0" anchor="ctr">
+            <a:spAutoFit/>
+          </a:bodyPr>
+          <a:lstStyle/>
+          <a:p>
+            <a:pPr algn="ctr"/>
+            <a:r>
+              <a:rPr lang="en-US" dirty="0">
+                <a:solidFill>
+                  <a:srgbClr val="5BC0DE"/>
+                </a:solidFill>
+                <a:latin typeface="Roboto" panose="02000000000000000000" pitchFamily="2" charset="0"/>
+                <a:ea typeface="Roboto" panose="02000000000000000000" pitchFamily="2" charset="0"/>
+              </a:rPr>
+              <a:t>Highlight Accent #5BC0DE</a:t>
+            </a:r>
+          </a:p>
+        </p:txBody>
+      </p:sp>
+    </p:spTree>
+    <p:extLst>
+      <p:ext uri="{BB962C8B-B14F-4D97-AF65-F5344CB8AC3E}">
+        <p14:creationId xmlns:p14="http://schemas.microsoft.com/office/powerpoint/2010/main" val="4039783117"/>
+      </p:ext>
+    </p:extLst>
+  </p:cSld>
+  <p:clrMapOvr>
+    <a:masterClrMapping/>
+  </p:clrMapOvr>
+</p:sld>
+</file>
+
+<file path=ppt/slides/slide4.xml><?xml version="1.0" encoding="utf-8"?>
+<p:sld xmlns:a="http://schemas.openxmlformats.org/drawingml/2006/main" xmlns:r="http://schemas.openxmlformats.org/officeDocument/2006/relationships" xmlns:p="http://schemas.openxmlformats.org/presentationml/2006/main">
+  <p:cSld>
+    <p:bg>
+      <p:bgPr>
+        <a:solidFill>
+          <a:srgbClr val="141818"/>
+        </a:solidFill>
+        <a:effectLst/>
+      </p:bgPr>
+    </p:bg>
+    <p:spTree>
+      <p:nvGrpSpPr>
+        <p:cNvPr id="1" name="">
+          <a:extLst>
+            <a:ext uri="{FF2B5EF4-FFF2-40B4-BE49-F238E27FC236}">
+              <a16:creationId xmlns:a16="http://schemas.microsoft.com/office/drawing/2014/main" id="{4D0520D8-712C-F5EC-4993-F4EFD27E9767}"/>
+            </a:ext>
+          </a:extLst>
+        </p:cNvPr>
+        <p:cNvGrpSpPr/>
+        <p:nvPr/>
+      </p:nvGrpSpPr>
+      <p:grpSpPr>
+        <a:xfrm>
+          <a:off x="0" y="0"/>
+          <a:ext cx="0" cy="0"/>
+          <a:chOff x="0" y="0"/>
+          <a:chExt cx="0" cy="0"/>
+        </a:xfrm>
+      </p:grpSpPr>
+      <p:sp>
+        <p:nvSpPr>
+          <p:cNvPr id="5" name="TextBox 4">
+            <a:extLst>
+              <a:ext uri="{FF2B5EF4-FFF2-40B4-BE49-F238E27FC236}">
+                <a16:creationId xmlns:a16="http://schemas.microsoft.com/office/drawing/2014/main" id="{0EE19097-99AF-2CEC-2338-53002F06C62D}"/>
+              </a:ext>
+            </a:extLst>
+          </p:cNvPr>
+          <p:cNvSpPr txBox="1"/>
+          <p:nvPr/>
+        </p:nvSpPr>
+        <p:spPr>
+          <a:xfrm>
+            <a:off x="3800475" y="124975"/>
+            <a:ext cx="4572000" cy="457200"/>
+          </a:xfrm>
+          <a:prstGeom prst="roundRect">
+            <a:avLst/>
+          </a:prstGeom>
+          <a:solidFill>
+            <a:srgbClr val="23282A"/>
+          </a:solidFill>
+          <a:ln w="28575">
+            <a:solidFill>
+              <a:srgbClr val="64D5D2"/>
+            </a:solidFill>
+          </a:ln>
+        </p:spPr>
+        <p:style>
+          <a:lnRef idx="2">
+            <a:schemeClr val="accent5"/>
+          </a:lnRef>
+          <a:fillRef idx="1">
+            <a:schemeClr val="lt1"/>
+          </a:fillRef>
+          <a:effectRef idx="0">
+            <a:schemeClr val="accent5"/>
+          </a:effectRef>
+          <a:fontRef idx="minor">
+            <a:schemeClr val="dk1"/>
+          </a:fontRef>
+        </p:style>
+        <p:txBody>
+          <a:bodyPr wrap="square" rtlCol="0" anchor="ctr">
+            <a:noAutofit/>
+          </a:bodyPr>
+          <a:lstStyle/>
+          <a:p>
+            <a:pPr algn="ctr"/>
+            <a:r>
+              <a:rPr lang="en-US" b="1" i="1" dirty="0">
+                <a:solidFill>
+                  <a:srgbClr val="FAFAFA"/>
+                </a:solidFill>
+                <a:latin typeface="Roboto" panose="02000000000000000000" pitchFamily="2" charset="0"/>
+                <a:ea typeface="Roboto" panose="02000000000000000000" pitchFamily="2" charset="0"/>
+              </a:rPr>
+              <a:t>Journey to Drone Swarm Light Shows</a:t>
+            </a:r>
+          </a:p>
+        </p:txBody>
+      </p:sp>
+      <p:sp>
+        <p:nvSpPr>
+          <p:cNvPr id="2" name="TextBox 1">
+            <a:extLst>
+              <a:ext uri="{FF2B5EF4-FFF2-40B4-BE49-F238E27FC236}">
+                <a16:creationId xmlns:a16="http://schemas.microsoft.com/office/drawing/2014/main" id="{1DE098DB-9077-7E37-911A-F21AC5308369}"/>
+              </a:ext>
+            </a:extLst>
+          </p:cNvPr>
+          <p:cNvSpPr txBox="1"/>
+          <p:nvPr/>
+        </p:nvSpPr>
+        <p:spPr>
+          <a:xfrm>
+            <a:off x="843645" y="1069681"/>
+            <a:ext cx="3200400" cy="1828800"/>
+          </a:xfrm>
+          <a:prstGeom prst="roundRect">
+            <a:avLst/>
+          </a:prstGeom>
+          <a:solidFill>
+            <a:srgbClr val="23282A"/>
+          </a:solidFill>
+          <a:ln w="28575">
+            <a:solidFill>
+              <a:srgbClr val="DAF842"/>
+            </a:solidFill>
+          </a:ln>
+          <a:effectLst>
+            <a:glow rad="63500">
+              <a:srgbClr val="DAF842">
+                <a:alpha val="72000"/>
+              </a:srgbClr>
+            </a:glow>
+          </a:effectLst>
+        </p:spPr>
+        <p:style>
+          <a:lnRef idx="2">
+            <a:schemeClr val="accent5"/>
+          </a:lnRef>
+          <a:fillRef idx="1">
+            <a:schemeClr val="lt1"/>
+          </a:fillRef>
+          <a:effectRef idx="0">
+            <a:schemeClr val="accent5"/>
+          </a:effectRef>
+          <a:fontRef idx="minor">
+            <a:schemeClr val="dk1"/>
+          </a:fontRef>
+        </p:style>
+        <p:txBody>
+          <a:bodyPr wrap="square" lIns="0" rIns="0" rtlCol="0" anchor="ctr">
+            <a:noAutofit/>
+          </a:bodyPr>
+          <a:lstStyle/>
+          <a:p>
+            <a:pPr algn="ctr"/>
+            <a:r>
+              <a:rPr lang="en-US" b="1" i="1" dirty="0">
+                <a:solidFill>
+                  <a:srgbClr val="5BC0DE"/>
+                </a:solidFill>
+                <a:latin typeface="Roboto" panose="02000000000000000000" pitchFamily="2" charset="0"/>
+                <a:ea typeface="Roboto" panose="02000000000000000000" pitchFamily="2" charset="0"/>
+              </a:rPr>
+              <a:t>Phase 1: Prototype Remote Control System</a:t>
+            </a:r>
+          </a:p>
+          <a:p>
+            <a:pPr marL="171450" indent="-171450">
+              <a:buFont typeface="Arial" panose="020B0604020202020204" pitchFamily="34" charset="0"/>
+              <a:buChar char="•"/>
+            </a:pPr>
+            <a:endParaRPr lang="en-US" sz="1200" dirty="0">
+              <a:solidFill>
+                <a:srgbClr val="5BC0DE"/>
+              </a:solidFill>
+              <a:latin typeface="Roboto" panose="02000000000000000000" pitchFamily="2" charset="0"/>
+              <a:ea typeface="Roboto" panose="02000000000000000000" pitchFamily="2" charset="0"/>
+            </a:endParaRPr>
+          </a:p>
+          <a:p>
+            <a:pPr marL="171450" indent="-171450">
+              <a:buFont typeface="Arial" panose="020B0604020202020204" pitchFamily="34" charset="0"/>
+              <a:buChar char="•"/>
+            </a:pPr>
+            <a:r>
+              <a:rPr lang="en-US" sz="1200" dirty="0">
+                <a:solidFill>
+                  <a:srgbClr val="FAFAFA"/>
+                </a:solidFill>
+                <a:latin typeface="Roboto" panose="02000000000000000000" pitchFamily="2" charset="0"/>
+                <a:ea typeface="Roboto" panose="02000000000000000000" pitchFamily="2" charset="0"/>
+              </a:rPr>
+              <a:t>Build a wireless controller using </a:t>
+            </a:r>
+            <a:r>
+              <a:rPr lang="en-US" sz="1200">
+                <a:solidFill>
+                  <a:srgbClr val="FAFAFA"/>
+                </a:solidFill>
+                <a:latin typeface="Roboto" panose="02000000000000000000" pitchFamily="2" charset="0"/>
+                <a:ea typeface="Roboto" panose="02000000000000000000" pitchFamily="2" charset="0"/>
+              </a:rPr>
+              <a:t>a DualShock4, </a:t>
+            </a:r>
+            <a:r>
+              <a:rPr lang="en-US" sz="1200" dirty="0">
+                <a:solidFill>
+                  <a:srgbClr val="FAFAFA"/>
+                </a:solidFill>
+                <a:latin typeface="Roboto" panose="02000000000000000000" pitchFamily="2" charset="0"/>
+                <a:ea typeface="Roboto" panose="02000000000000000000" pitchFamily="2" charset="0"/>
+              </a:rPr>
+              <a:t>Arduino, </a:t>
+            </a:r>
+            <a:r>
+              <a:rPr lang="en-US" sz="1200" dirty="0" err="1">
+                <a:solidFill>
+                  <a:srgbClr val="FAFAFA"/>
+                </a:solidFill>
+                <a:latin typeface="Roboto" panose="02000000000000000000" pitchFamily="2" charset="0"/>
+                <a:ea typeface="Roboto" panose="02000000000000000000" pitchFamily="2" charset="0"/>
+              </a:rPr>
+              <a:t>XBee</a:t>
+            </a:r>
+            <a:r>
+              <a:rPr lang="en-US" sz="1200" dirty="0">
+                <a:solidFill>
+                  <a:srgbClr val="FAFAFA"/>
+                </a:solidFill>
+                <a:latin typeface="Roboto" panose="02000000000000000000" pitchFamily="2" charset="0"/>
+                <a:ea typeface="Roboto" panose="02000000000000000000" pitchFamily="2" charset="0"/>
+              </a:rPr>
+              <a:t> radio, and OLED screen.</a:t>
+            </a:r>
+          </a:p>
+          <a:p>
+            <a:pPr marL="171450" indent="-171450">
+              <a:buFont typeface="Arial" panose="020B0604020202020204" pitchFamily="34" charset="0"/>
+              <a:buChar char="•"/>
+            </a:pPr>
+            <a:r>
+              <a:rPr lang="en-US" sz="1200" dirty="0">
+                <a:solidFill>
+                  <a:srgbClr val="FAFAFA"/>
+                </a:solidFill>
+                <a:latin typeface="Roboto" panose="02000000000000000000" pitchFamily="2" charset="0"/>
+                <a:ea typeface="Roboto" panose="02000000000000000000" pitchFamily="2" charset="0"/>
+              </a:rPr>
+              <a:t>Establish a standard protocol for sending commands and receiving telemetry.</a:t>
+            </a:r>
+          </a:p>
+        </p:txBody>
+      </p:sp>
+      <p:sp>
+        <p:nvSpPr>
+          <p:cNvPr id="7" name="TextBox 6">
+            <a:extLst>
+              <a:ext uri="{FF2B5EF4-FFF2-40B4-BE49-F238E27FC236}">
+                <a16:creationId xmlns:a16="http://schemas.microsoft.com/office/drawing/2014/main" id="{28DB10A2-5DF1-53F6-98F5-22A77BD495A5}"/>
+              </a:ext>
+            </a:extLst>
+          </p:cNvPr>
+          <p:cNvSpPr txBox="1"/>
+          <p:nvPr/>
+        </p:nvSpPr>
+        <p:spPr>
+          <a:xfrm>
+            <a:off x="4495799" y="1069681"/>
+            <a:ext cx="3200400" cy="1828800"/>
+          </a:xfrm>
+          <a:prstGeom prst="roundRect">
+            <a:avLst/>
+          </a:prstGeom>
+          <a:solidFill>
+            <a:srgbClr val="23282A"/>
+          </a:solidFill>
+          <a:ln w="28575">
+            <a:solidFill>
+              <a:srgbClr val="64D5D2"/>
+            </a:solidFill>
+          </a:ln>
+        </p:spPr>
+        <p:style>
+          <a:lnRef idx="2">
+            <a:schemeClr val="accent5"/>
+          </a:lnRef>
+          <a:fillRef idx="1">
+            <a:schemeClr val="lt1"/>
+          </a:fillRef>
+          <a:effectRef idx="0">
+            <a:schemeClr val="accent5"/>
+          </a:effectRef>
+          <a:fontRef idx="minor">
+            <a:schemeClr val="dk1"/>
+          </a:fontRef>
+        </p:style>
+        <p:txBody>
+          <a:bodyPr wrap="square" lIns="0" rIns="0" rtlCol="0" anchor="ctr">
+            <a:noAutofit/>
+          </a:bodyPr>
+          <a:lstStyle>
+            <a:defPPr>
+              <a:defRPr lang="en-US"/>
+            </a:defPPr>
+            <a:lvl1pPr algn="ctr">
+              <a:defRPr>
+                <a:solidFill>
+                  <a:srgbClr val="FAFAFA"/>
+                </a:solidFill>
+                <a:latin typeface="Roboto" panose="02000000000000000000" pitchFamily="2" charset="0"/>
+                <a:ea typeface="Roboto" panose="02000000000000000000" pitchFamily="2" charset="0"/>
+              </a:defRPr>
+            </a:lvl1pPr>
+          </a:lstStyle>
+          <a:p>
+            <a:r>
+              <a:rPr lang="en-US" b="1" i="1" dirty="0">
+                <a:solidFill>
+                  <a:srgbClr val="5BC0DE"/>
+                </a:solidFill>
+              </a:rPr>
+              <a:t>Phase 2: Rover Teleoperation (DualShock4)</a:t>
+            </a:r>
+          </a:p>
+          <a:p>
+            <a:pPr marL="171450" indent="-171450" algn="l">
+              <a:buFont typeface="Arial" panose="020B0604020202020204" pitchFamily="34" charset="0"/>
+              <a:buChar char="•"/>
+            </a:pPr>
+            <a:endParaRPr lang="en-US" sz="1200" dirty="0">
+              <a:solidFill>
+                <a:srgbClr val="5BC0DE"/>
+              </a:solidFill>
+            </a:endParaRPr>
+          </a:p>
+          <a:p>
+            <a:pPr marL="171450" indent="-171450" algn="l">
+              <a:buFont typeface="Arial" panose="020B0604020202020204" pitchFamily="34" charset="0"/>
+              <a:buChar char="•"/>
+            </a:pPr>
+            <a:r>
+              <a:rPr lang="en-US" sz="1200" dirty="0"/>
+              <a:t>Test remote control on a simple rover using the new wireless system.</a:t>
+            </a:r>
+          </a:p>
+          <a:p>
+            <a:pPr marL="171450" indent="-171450" algn="l">
+              <a:buFont typeface="Arial" panose="020B0604020202020204" pitchFamily="34" charset="0"/>
+              <a:buChar char="•"/>
+            </a:pPr>
+            <a:r>
+              <a:rPr lang="en-US" sz="1200" dirty="0"/>
+              <a:t>Verify reliable two-way communication and refine command handling.</a:t>
+            </a:r>
+          </a:p>
+        </p:txBody>
+      </p:sp>
+      <p:cxnSp>
+        <p:nvCxnSpPr>
+          <p:cNvPr id="22" name="Straight Arrow Connector 21">
+            <a:extLst>
+              <a:ext uri="{FF2B5EF4-FFF2-40B4-BE49-F238E27FC236}">
+                <a16:creationId xmlns:a16="http://schemas.microsoft.com/office/drawing/2014/main" id="{150BFC73-5B9C-FA74-8F95-EEFD63D3814F}"/>
+              </a:ext>
+            </a:extLst>
+          </p:cNvPr>
+          <p:cNvCxnSpPr>
+            <a:cxnSpLocks/>
+          </p:cNvCxnSpPr>
+          <p:nvPr/>
+        </p:nvCxnSpPr>
+        <p:spPr>
+          <a:xfrm>
+            <a:off x="4044045" y="1984081"/>
+            <a:ext cx="454478" cy="0"/>
+          </a:xfrm>
+          <a:prstGeom prst="straightConnector1">
+            <a:avLst/>
+          </a:prstGeom>
+          <a:ln>
+            <a:solidFill>
+              <a:srgbClr val="5BC0DE"/>
+            </a:solidFill>
+            <a:tailEnd type="triangle"/>
+          </a:ln>
+        </p:spPr>
+        <p:style>
+          <a:lnRef idx="1">
+            <a:schemeClr val="accent1"/>
+          </a:lnRef>
+          <a:fillRef idx="0">
+            <a:schemeClr val="accent1"/>
+          </a:fillRef>
+          <a:effectRef idx="0">
+            <a:schemeClr val="accent1"/>
+          </a:effectRef>
+          <a:fontRef idx="minor">
+            <a:schemeClr val="tx1"/>
+          </a:fontRef>
+        </p:style>
+      </p:cxnSp>
+      <p:sp>
+        <p:nvSpPr>
+          <p:cNvPr id="61" name="TextBox 60">
+            <a:extLst>
+              <a:ext uri="{FF2B5EF4-FFF2-40B4-BE49-F238E27FC236}">
+                <a16:creationId xmlns:a16="http://schemas.microsoft.com/office/drawing/2014/main" id="{5942CB95-89EB-F181-CD3B-146E81C9B005}"/>
+              </a:ext>
+            </a:extLst>
+          </p:cNvPr>
+          <p:cNvSpPr txBox="1"/>
+          <p:nvPr/>
+        </p:nvSpPr>
+        <p:spPr>
+          <a:xfrm>
+            <a:off x="8147957" y="1069681"/>
+            <a:ext cx="3200400" cy="1828800"/>
+          </a:xfrm>
+          <a:prstGeom prst="roundRect">
+            <a:avLst/>
+          </a:prstGeom>
+          <a:solidFill>
+            <a:srgbClr val="23282A"/>
+          </a:solidFill>
+          <a:ln w="28575">
+            <a:solidFill>
+              <a:srgbClr val="64D5D2"/>
+            </a:solidFill>
+          </a:ln>
+        </p:spPr>
+        <p:style>
+          <a:lnRef idx="2">
+            <a:schemeClr val="accent5"/>
+          </a:lnRef>
+          <a:fillRef idx="1">
+            <a:schemeClr val="lt1"/>
+          </a:fillRef>
+          <a:effectRef idx="0">
+            <a:schemeClr val="accent5"/>
+          </a:effectRef>
+          <a:fontRef idx="minor">
+            <a:schemeClr val="dk1"/>
+          </a:fontRef>
+        </p:style>
+        <p:txBody>
+          <a:bodyPr wrap="square" lIns="0" rIns="0" rtlCol="0" anchor="ctr">
+            <a:noAutofit/>
+          </a:bodyPr>
+          <a:lstStyle>
+            <a:defPPr>
+              <a:defRPr lang="en-US"/>
+            </a:defPPr>
+            <a:lvl1pPr algn="ctr">
+              <a:defRPr>
+                <a:solidFill>
+                  <a:srgbClr val="FAFAFA"/>
+                </a:solidFill>
+                <a:latin typeface="Roboto" panose="02000000000000000000" pitchFamily="2" charset="0"/>
+                <a:ea typeface="Roboto" panose="02000000000000000000" pitchFamily="2" charset="0"/>
+              </a:defRPr>
+            </a:lvl1pPr>
+          </a:lstStyle>
+          <a:p>
+            <a:r>
+              <a:rPr lang="en-US" b="1" i="1" dirty="0">
+                <a:solidFill>
+                  <a:srgbClr val="5BC0DE"/>
+                </a:solidFill>
+              </a:rPr>
+              <a:t>Phase 3: Mesh Networking &amp; Range Testing</a:t>
+            </a:r>
+          </a:p>
+          <a:p>
+            <a:pPr marL="171450" indent="-171450" algn="l">
+              <a:buFont typeface="Arial" panose="020B0604020202020204" pitchFamily="34" charset="0"/>
+              <a:buChar char="•"/>
+            </a:pPr>
+            <a:endParaRPr lang="en-US" sz="1200" dirty="0">
+              <a:solidFill>
+                <a:srgbClr val="5BC0DE"/>
+              </a:solidFill>
+            </a:endParaRPr>
+          </a:p>
+          <a:p>
+            <a:pPr marL="171450" indent="-171450" algn="l">
+              <a:buFont typeface="Arial" panose="020B0604020202020204" pitchFamily="34" charset="0"/>
+              <a:buChar char="•"/>
+            </a:pPr>
+            <a:r>
+              <a:rPr lang="en-US" sz="1200" dirty="0"/>
+              <a:t>Experiment with </a:t>
+            </a:r>
+            <a:r>
+              <a:rPr lang="en-US" sz="1200" dirty="0" err="1"/>
+              <a:t>XBee</a:t>
+            </a:r>
+            <a:r>
+              <a:rPr lang="en-US" sz="1200" dirty="0"/>
+              <a:t> mesh networking to extend control range.</a:t>
+            </a:r>
+          </a:p>
+          <a:p>
+            <a:pPr marL="171450" indent="-171450" algn="l">
+              <a:buFont typeface="Arial" panose="020B0604020202020204" pitchFamily="34" charset="0"/>
+              <a:buChar char="•"/>
+            </a:pPr>
+            <a:r>
+              <a:rPr lang="en-US" sz="1200" dirty="0"/>
+              <a:t>Assess communication reliability with multiple nodes in real-world conditions.</a:t>
+            </a:r>
+          </a:p>
+        </p:txBody>
+      </p:sp>
+      <p:sp>
+        <p:nvSpPr>
+          <p:cNvPr id="63" name="TextBox 62">
+            <a:extLst>
+              <a:ext uri="{FF2B5EF4-FFF2-40B4-BE49-F238E27FC236}">
+                <a16:creationId xmlns:a16="http://schemas.microsoft.com/office/drawing/2014/main" id="{20BD9FE9-BB90-9855-F0C1-8EAB7A4847F3}"/>
+              </a:ext>
+            </a:extLst>
+          </p:cNvPr>
+          <p:cNvSpPr txBox="1"/>
+          <p:nvPr/>
+        </p:nvSpPr>
+        <p:spPr>
+          <a:xfrm>
+            <a:off x="849090" y="3312651"/>
+            <a:ext cx="3200400" cy="1828800"/>
+          </a:xfrm>
+          <a:prstGeom prst="roundRect">
+            <a:avLst/>
+          </a:prstGeom>
+          <a:solidFill>
+            <a:srgbClr val="23282A"/>
+          </a:solidFill>
+          <a:ln w="28575">
+            <a:solidFill>
+              <a:srgbClr val="64D5D2"/>
+            </a:solidFill>
+          </a:ln>
+        </p:spPr>
+        <p:style>
+          <a:lnRef idx="2">
+            <a:schemeClr val="accent5"/>
+          </a:lnRef>
+          <a:fillRef idx="1">
+            <a:schemeClr val="lt1"/>
+          </a:fillRef>
+          <a:effectRef idx="0">
+            <a:schemeClr val="accent5"/>
+          </a:effectRef>
+          <a:fontRef idx="minor">
+            <a:schemeClr val="dk1"/>
+          </a:fontRef>
+        </p:style>
+        <p:txBody>
+          <a:bodyPr wrap="square" lIns="0" rIns="0" rtlCol="0" anchor="ctr">
+            <a:noAutofit/>
+          </a:bodyPr>
+          <a:lstStyle>
+            <a:defPPr>
+              <a:defRPr lang="en-US"/>
+            </a:defPPr>
+            <a:lvl1pPr algn="ctr">
+              <a:defRPr>
+                <a:solidFill>
+                  <a:srgbClr val="FAFAFA"/>
+                </a:solidFill>
+                <a:latin typeface="Roboto" panose="02000000000000000000" pitchFamily="2" charset="0"/>
+                <a:ea typeface="Roboto" panose="02000000000000000000" pitchFamily="2" charset="0"/>
+              </a:defRPr>
+            </a:lvl1pPr>
+          </a:lstStyle>
+          <a:p>
+            <a:r>
+              <a:rPr lang="en-US" b="1" i="1" dirty="0">
+                <a:solidFill>
+                  <a:srgbClr val="5BC0DE"/>
+                </a:solidFill>
+              </a:rPr>
+              <a:t>Phase 4: Swarm Controller Development</a:t>
+            </a:r>
+          </a:p>
+          <a:p>
+            <a:pPr marL="171450" indent="-171450" algn="l">
+              <a:buFont typeface="Arial" panose="020B0604020202020204" pitchFamily="34" charset="0"/>
+              <a:buChar char="•"/>
+            </a:pPr>
+            <a:endParaRPr lang="en-US" sz="1200" dirty="0">
+              <a:solidFill>
+                <a:srgbClr val="5BC0DE"/>
+              </a:solidFill>
+            </a:endParaRPr>
+          </a:p>
+          <a:p>
+            <a:pPr marL="171450" indent="-171450" algn="l">
+              <a:buFont typeface="Arial" panose="020B0604020202020204" pitchFamily="34" charset="0"/>
+              <a:buChar char="•"/>
+            </a:pPr>
+            <a:r>
+              <a:rPr lang="en-US" sz="1200" dirty="0"/>
+              <a:t>Expand system to support controlling multiple vehicles.</a:t>
+            </a:r>
+          </a:p>
+          <a:p>
+            <a:pPr marL="171450" indent="-171450" algn="l">
+              <a:buFont typeface="Arial" panose="020B0604020202020204" pitchFamily="34" charset="0"/>
+              <a:buChar char="•"/>
+            </a:pPr>
+            <a:r>
+              <a:rPr lang="en-US" sz="1200" dirty="0"/>
+              <a:t>Add synchronized command features and basic group coordination.</a:t>
+            </a:r>
+          </a:p>
+        </p:txBody>
+      </p:sp>
+      <p:sp>
+        <p:nvSpPr>
+          <p:cNvPr id="64" name="TextBox 63">
+            <a:extLst>
+              <a:ext uri="{FF2B5EF4-FFF2-40B4-BE49-F238E27FC236}">
+                <a16:creationId xmlns:a16="http://schemas.microsoft.com/office/drawing/2014/main" id="{1CD9CFC1-6612-057D-6B6A-17BD14C81722}"/>
+              </a:ext>
+            </a:extLst>
+          </p:cNvPr>
+          <p:cNvSpPr txBox="1"/>
+          <p:nvPr/>
+        </p:nvSpPr>
+        <p:spPr>
+          <a:xfrm>
+            <a:off x="4495799" y="3312651"/>
+            <a:ext cx="3200400" cy="1828800"/>
+          </a:xfrm>
+          <a:prstGeom prst="roundRect">
+            <a:avLst/>
+          </a:prstGeom>
+          <a:solidFill>
+            <a:srgbClr val="23282A"/>
+          </a:solidFill>
+          <a:ln w="28575">
+            <a:solidFill>
+              <a:srgbClr val="64D5D2"/>
+            </a:solidFill>
+          </a:ln>
+        </p:spPr>
+        <p:style>
+          <a:lnRef idx="2">
+            <a:schemeClr val="accent5"/>
+          </a:lnRef>
+          <a:fillRef idx="1">
+            <a:schemeClr val="lt1"/>
+          </a:fillRef>
+          <a:effectRef idx="0">
+            <a:schemeClr val="accent5"/>
+          </a:effectRef>
+          <a:fontRef idx="minor">
+            <a:schemeClr val="dk1"/>
+          </a:fontRef>
+        </p:style>
+        <p:txBody>
+          <a:bodyPr wrap="square" lIns="0" rIns="0" rtlCol="0" anchor="ctr">
+            <a:noAutofit/>
+          </a:bodyPr>
+          <a:lstStyle>
+            <a:defPPr>
+              <a:defRPr lang="en-US"/>
+            </a:defPPr>
+            <a:lvl1pPr algn="ctr">
+              <a:defRPr>
+                <a:solidFill>
+                  <a:srgbClr val="FAFAFA"/>
+                </a:solidFill>
+                <a:latin typeface="Roboto" panose="02000000000000000000" pitchFamily="2" charset="0"/>
+                <a:ea typeface="Roboto" panose="02000000000000000000" pitchFamily="2" charset="0"/>
+              </a:defRPr>
+            </a:lvl1pPr>
+          </a:lstStyle>
+          <a:p>
+            <a:r>
+              <a:rPr lang="en-US" b="1" i="1" dirty="0">
+                <a:solidFill>
+                  <a:srgbClr val="5BC0DE"/>
+                </a:solidFill>
+              </a:rPr>
+              <a:t>Phase 5: Integration with Flight Controllers (</a:t>
+            </a:r>
+            <a:r>
+              <a:rPr lang="en-US" b="1" i="1" dirty="0" err="1">
+                <a:solidFill>
+                  <a:srgbClr val="5BC0DE"/>
+                </a:solidFill>
+              </a:rPr>
+              <a:t>ArduPilot</a:t>
+            </a:r>
+            <a:r>
+              <a:rPr lang="en-US" b="1" i="1" dirty="0">
+                <a:solidFill>
+                  <a:srgbClr val="5BC0DE"/>
+                </a:solidFill>
+              </a:rPr>
+              <a:t>)</a:t>
+            </a:r>
+          </a:p>
+          <a:p>
+            <a:endParaRPr lang="en-US" sz="1200" dirty="0">
+              <a:solidFill>
+                <a:srgbClr val="5BC0DE"/>
+              </a:solidFill>
+            </a:endParaRPr>
+          </a:p>
+          <a:p>
+            <a:pPr marL="171450" indent="-171450" algn="l">
+              <a:buFont typeface="Arial" panose="020B0604020202020204" pitchFamily="34" charset="0"/>
+              <a:buChar char="•"/>
+            </a:pPr>
+            <a:r>
+              <a:rPr lang="en-US" sz="1200" dirty="0"/>
+              <a:t>Upgrade to professional-grade flight controllers for advanced features.</a:t>
+            </a:r>
+          </a:p>
+          <a:p>
+            <a:pPr marL="171450" indent="-171450" algn="l">
+              <a:buFont typeface="Arial" panose="020B0604020202020204" pitchFamily="34" charset="0"/>
+              <a:buChar char="•"/>
+            </a:pPr>
+            <a:r>
+              <a:rPr lang="en-US" sz="1200" dirty="0"/>
+              <a:t>Integrate command and telemetry protocol with </a:t>
+            </a:r>
+            <a:r>
+              <a:rPr lang="en-US" sz="1200" dirty="0" err="1"/>
+              <a:t>ArduPilot</a:t>
+            </a:r>
+            <a:r>
+              <a:rPr lang="en-US" sz="1200" dirty="0"/>
+              <a:t> systems.</a:t>
+            </a:r>
+          </a:p>
+        </p:txBody>
+      </p:sp>
+      <p:sp>
+        <p:nvSpPr>
+          <p:cNvPr id="65" name="TextBox 64">
+            <a:extLst>
+              <a:ext uri="{FF2B5EF4-FFF2-40B4-BE49-F238E27FC236}">
+                <a16:creationId xmlns:a16="http://schemas.microsoft.com/office/drawing/2014/main" id="{D30198D0-C5AF-A638-1D8B-E14121A53C82}"/>
+              </a:ext>
+            </a:extLst>
+          </p:cNvPr>
+          <p:cNvSpPr txBox="1"/>
+          <p:nvPr/>
+        </p:nvSpPr>
+        <p:spPr>
+          <a:xfrm>
+            <a:off x="8147955" y="3312651"/>
+            <a:ext cx="3200400" cy="1828800"/>
+          </a:xfrm>
+          <a:prstGeom prst="roundRect">
+            <a:avLst/>
+          </a:prstGeom>
+          <a:solidFill>
+            <a:srgbClr val="23282A"/>
+          </a:solidFill>
+          <a:ln w="28575">
+            <a:solidFill>
+              <a:srgbClr val="64D5D2"/>
+            </a:solidFill>
+          </a:ln>
+        </p:spPr>
+        <p:style>
+          <a:lnRef idx="2">
+            <a:schemeClr val="accent5"/>
+          </a:lnRef>
+          <a:fillRef idx="1">
+            <a:schemeClr val="lt1"/>
+          </a:fillRef>
+          <a:effectRef idx="0">
+            <a:schemeClr val="accent5"/>
+          </a:effectRef>
+          <a:fontRef idx="minor">
+            <a:schemeClr val="dk1"/>
+          </a:fontRef>
+        </p:style>
+        <p:txBody>
+          <a:bodyPr wrap="square" lIns="0" rIns="0" rtlCol="0" anchor="ctr">
+            <a:noAutofit/>
+          </a:bodyPr>
+          <a:lstStyle>
+            <a:defPPr>
+              <a:defRPr lang="en-US"/>
+            </a:defPPr>
+            <a:lvl1pPr algn="ctr">
+              <a:defRPr>
+                <a:solidFill>
+                  <a:srgbClr val="FAFAFA"/>
+                </a:solidFill>
+                <a:latin typeface="Roboto" panose="02000000000000000000" pitchFamily="2" charset="0"/>
+                <a:ea typeface="Roboto" panose="02000000000000000000" pitchFamily="2" charset="0"/>
+              </a:defRPr>
+            </a:lvl1pPr>
+          </a:lstStyle>
+          <a:p>
+            <a:r>
+              <a:rPr lang="en-US" b="1" i="1" dirty="0">
+                <a:solidFill>
+                  <a:srgbClr val="5BC0DE"/>
+                </a:solidFill>
+              </a:rPr>
+              <a:t>Phase 6: Drone Swarm Simulation</a:t>
+            </a:r>
+          </a:p>
+          <a:p>
+            <a:pPr marL="171450" indent="-171450" algn="l">
+              <a:buFont typeface="Arial" panose="020B0604020202020204" pitchFamily="34" charset="0"/>
+              <a:buChar char="•"/>
+            </a:pPr>
+            <a:endParaRPr lang="en-US" sz="1200" dirty="0">
+              <a:solidFill>
+                <a:srgbClr val="5BC0DE"/>
+              </a:solidFill>
+            </a:endParaRPr>
+          </a:p>
+          <a:p>
+            <a:pPr marL="171450" indent="-171450" algn="l">
+              <a:buFont typeface="Arial" panose="020B0604020202020204" pitchFamily="34" charset="0"/>
+              <a:buChar char="•"/>
+            </a:pPr>
+            <a:r>
+              <a:rPr lang="en-US" sz="1200" dirty="0"/>
+              <a:t>Simulate swarm coordination and light show choreography in software.</a:t>
+            </a:r>
+          </a:p>
+          <a:p>
+            <a:pPr marL="171450" indent="-171450" algn="l">
+              <a:buFont typeface="Arial" panose="020B0604020202020204" pitchFamily="34" charset="0"/>
+              <a:buChar char="•"/>
+            </a:pPr>
+            <a:r>
+              <a:rPr lang="en-US" sz="1200" dirty="0"/>
+              <a:t>Test and refine group commands and synchronization logic before live tests.</a:t>
+            </a:r>
+          </a:p>
+        </p:txBody>
+      </p:sp>
+      <p:sp>
+        <p:nvSpPr>
+          <p:cNvPr id="71" name="TextBox 70">
+            <a:extLst>
+              <a:ext uri="{FF2B5EF4-FFF2-40B4-BE49-F238E27FC236}">
+                <a16:creationId xmlns:a16="http://schemas.microsoft.com/office/drawing/2014/main" id="{48A619B7-A276-3EED-833B-66282066C83B}"/>
+              </a:ext>
+            </a:extLst>
+          </p:cNvPr>
+          <p:cNvSpPr txBox="1"/>
+          <p:nvPr/>
+        </p:nvSpPr>
+        <p:spPr>
+          <a:xfrm>
+            <a:off x="3343275" y="5539647"/>
+            <a:ext cx="5486400" cy="1143000"/>
+          </a:xfrm>
+          <a:prstGeom prst="roundRect">
+            <a:avLst/>
+          </a:prstGeom>
+          <a:solidFill>
+            <a:srgbClr val="23282A"/>
+          </a:solidFill>
+          <a:ln w="28575">
+            <a:solidFill>
+              <a:srgbClr val="64D5D2"/>
+            </a:solidFill>
+          </a:ln>
+        </p:spPr>
+        <p:style>
+          <a:lnRef idx="2">
+            <a:schemeClr val="accent5"/>
+          </a:lnRef>
+          <a:fillRef idx="1">
+            <a:schemeClr val="lt1"/>
+          </a:fillRef>
+          <a:effectRef idx="0">
+            <a:schemeClr val="accent5"/>
+          </a:effectRef>
+          <a:fontRef idx="minor">
+            <a:schemeClr val="dk1"/>
+          </a:fontRef>
+        </p:style>
+        <p:txBody>
+          <a:bodyPr wrap="square" lIns="0" rIns="0" rtlCol="0" anchor="ctr">
+            <a:noAutofit/>
+          </a:bodyPr>
+          <a:lstStyle>
+            <a:defPPr>
+              <a:defRPr lang="en-US"/>
+            </a:defPPr>
+            <a:lvl1pPr algn="ctr">
+              <a:defRPr>
+                <a:solidFill>
+                  <a:srgbClr val="FAFAFA"/>
+                </a:solidFill>
+                <a:latin typeface="Roboto" panose="02000000000000000000" pitchFamily="2" charset="0"/>
+                <a:ea typeface="Roboto" panose="02000000000000000000" pitchFamily="2" charset="0"/>
+              </a:defRPr>
+            </a:lvl1pPr>
+          </a:lstStyle>
+          <a:p>
+            <a:r>
+              <a:rPr lang="en-US" b="1" i="1" dirty="0">
+                <a:solidFill>
+                  <a:srgbClr val="5BC0DE"/>
+                </a:solidFill>
+              </a:rPr>
+              <a:t>Phase 7: Live Swarm Light Show</a:t>
+            </a:r>
+          </a:p>
+          <a:p>
+            <a:pPr marL="171450" indent="-171450" algn="l">
+              <a:buFont typeface="Arial" panose="020B0604020202020204" pitchFamily="34" charset="0"/>
+              <a:buChar char="•"/>
+            </a:pPr>
+            <a:endParaRPr lang="en-US" sz="1200" dirty="0">
+              <a:solidFill>
+                <a:srgbClr val="5BC0DE"/>
+              </a:solidFill>
+            </a:endParaRPr>
+          </a:p>
+          <a:p>
+            <a:pPr marL="171450" indent="-171450" algn="l">
+              <a:buFont typeface="Arial" panose="020B0604020202020204" pitchFamily="34" charset="0"/>
+              <a:buChar char="•"/>
+            </a:pPr>
+            <a:r>
+              <a:rPr lang="en-US" sz="1200" dirty="0"/>
+              <a:t>Deploy multiple drones for a live, synchronized light show.</a:t>
+            </a:r>
+          </a:p>
+          <a:p>
+            <a:pPr marL="171450" indent="-171450" algn="l">
+              <a:buFont typeface="Arial" panose="020B0604020202020204" pitchFamily="34" charset="0"/>
+              <a:buChar char="•"/>
+            </a:pPr>
+            <a:r>
+              <a:rPr lang="en-US" sz="1200" dirty="0"/>
+              <a:t>Showcase complete system integration with real-world choreography.</a:t>
+            </a:r>
+          </a:p>
+        </p:txBody>
+      </p:sp>
+      <p:cxnSp>
+        <p:nvCxnSpPr>
+          <p:cNvPr id="72" name="Straight Arrow Connector 71">
+            <a:extLst>
+              <a:ext uri="{FF2B5EF4-FFF2-40B4-BE49-F238E27FC236}">
+                <a16:creationId xmlns:a16="http://schemas.microsoft.com/office/drawing/2014/main" id="{67EFF108-B4E2-CACF-25BE-66C9DE220138}"/>
+              </a:ext>
+            </a:extLst>
+          </p:cNvPr>
+          <p:cNvCxnSpPr>
+            <a:cxnSpLocks/>
+          </p:cNvCxnSpPr>
+          <p:nvPr/>
+        </p:nvCxnSpPr>
+        <p:spPr>
+          <a:xfrm>
+            <a:off x="7698923" y="1984081"/>
+            <a:ext cx="449034" cy="0"/>
+          </a:xfrm>
+          <a:prstGeom prst="straightConnector1">
+            <a:avLst/>
+          </a:prstGeom>
+          <a:ln>
+            <a:solidFill>
+              <a:srgbClr val="5BC0DE"/>
+            </a:solidFill>
+            <a:tailEnd type="triangle"/>
+          </a:ln>
+        </p:spPr>
+        <p:style>
+          <a:lnRef idx="1">
+            <a:schemeClr val="accent1"/>
+          </a:lnRef>
+          <a:fillRef idx="0">
+            <a:schemeClr val="accent1"/>
+          </a:fillRef>
+          <a:effectRef idx="0">
+            <a:schemeClr val="accent1"/>
+          </a:effectRef>
+          <a:fontRef idx="minor">
+            <a:schemeClr val="tx1"/>
+          </a:fontRef>
+        </p:style>
+      </p:cxnSp>
+      <p:cxnSp>
+        <p:nvCxnSpPr>
+          <p:cNvPr id="75" name="Straight Arrow Connector 74">
+            <a:extLst>
+              <a:ext uri="{FF2B5EF4-FFF2-40B4-BE49-F238E27FC236}">
+                <a16:creationId xmlns:a16="http://schemas.microsoft.com/office/drawing/2014/main" id="{0556B4D4-0859-60AD-754F-75622616F7EF}"/>
+              </a:ext>
+            </a:extLst>
+          </p:cNvPr>
+          <p:cNvCxnSpPr>
+            <a:cxnSpLocks/>
+          </p:cNvCxnSpPr>
+          <p:nvPr/>
+        </p:nvCxnSpPr>
+        <p:spPr>
+          <a:xfrm>
+            <a:off x="4049490" y="4227051"/>
+            <a:ext cx="449033" cy="0"/>
+          </a:xfrm>
+          <a:prstGeom prst="straightConnector1">
+            <a:avLst/>
+          </a:prstGeom>
+          <a:ln>
+            <a:solidFill>
+              <a:srgbClr val="5BC0DE"/>
+            </a:solidFill>
+            <a:tailEnd type="triangle"/>
+          </a:ln>
+        </p:spPr>
+        <p:style>
+          <a:lnRef idx="1">
+            <a:schemeClr val="accent1"/>
+          </a:lnRef>
+          <a:fillRef idx="0">
+            <a:schemeClr val="accent1"/>
+          </a:fillRef>
+          <a:effectRef idx="0">
+            <a:schemeClr val="accent1"/>
+          </a:effectRef>
+          <a:fontRef idx="minor">
+            <a:schemeClr val="tx1"/>
+          </a:fontRef>
+        </p:style>
+      </p:cxnSp>
+      <p:cxnSp>
+        <p:nvCxnSpPr>
+          <p:cNvPr id="79" name="Straight Arrow Connector 78">
+            <a:extLst>
+              <a:ext uri="{FF2B5EF4-FFF2-40B4-BE49-F238E27FC236}">
+                <a16:creationId xmlns:a16="http://schemas.microsoft.com/office/drawing/2014/main" id="{595F1812-55E8-53CD-F36B-6B45685A2377}"/>
+              </a:ext>
+            </a:extLst>
+          </p:cNvPr>
+          <p:cNvCxnSpPr>
+            <a:cxnSpLocks/>
+          </p:cNvCxnSpPr>
+          <p:nvPr/>
+        </p:nvCxnSpPr>
+        <p:spPr>
+          <a:xfrm>
+            <a:off x="7698923" y="4227051"/>
+            <a:ext cx="449032" cy="0"/>
+          </a:xfrm>
+          <a:prstGeom prst="straightConnector1">
+            <a:avLst/>
+          </a:prstGeom>
+          <a:ln>
+            <a:solidFill>
+              <a:srgbClr val="5BC0DE"/>
+            </a:solidFill>
+            <a:tailEnd type="triangle"/>
+          </a:ln>
+        </p:spPr>
+        <p:style>
+          <a:lnRef idx="1">
+            <a:schemeClr val="accent1"/>
+          </a:lnRef>
+          <a:fillRef idx="0">
+            <a:schemeClr val="accent1"/>
+          </a:fillRef>
+          <a:effectRef idx="0">
+            <a:schemeClr val="accent1"/>
+          </a:effectRef>
+          <a:fontRef idx="minor">
+            <a:schemeClr val="tx1"/>
+          </a:fontRef>
+        </p:style>
+      </p:cxnSp>
+      <p:cxnSp>
+        <p:nvCxnSpPr>
+          <p:cNvPr id="83" name="Connector: Elbow 82">
+            <a:extLst>
+              <a:ext uri="{FF2B5EF4-FFF2-40B4-BE49-F238E27FC236}">
+                <a16:creationId xmlns:a16="http://schemas.microsoft.com/office/drawing/2014/main" id="{8CD3C0EF-F550-BA83-81BB-3D3067C9C99D}"/>
+              </a:ext>
+            </a:extLst>
+          </p:cNvPr>
+          <p:cNvCxnSpPr>
+            <a:cxnSpLocks/>
+            <a:stCxn id="61" idx="3"/>
+            <a:endCxn id="63" idx="1"/>
+          </p:cNvCxnSpPr>
+          <p:nvPr/>
+        </p:nvCxnSpPr>
+        <p:spPr>
+          <a:xfrm flipH="1">
+            <a:off x="849090" y="1984081"/>
+            <a:ext cx="10499267" cy="2242970"/>
+          </a:xfrm>
+          <a:prstGeom prst="bentConnector5">
+            <a:avLst>
+              <a:gd name="adj1" fmla="val -2177"/>
+              <a:gd name="adj2" fmla="val 50000"/>
+              <a:gd name="adj3" fmla="val 102177"/>
+            </a:avLst>
+          </a:prstGeom>
+          <a:ln>
+            <a:solidFill>
+              <a:srgbClr val="64D5D2"/>
+            </a:solidFill>
+            <a:tailEnd type="triangle"/>
+          </a:ln>
+        </p:spPr>
+        <p:style>
+          <a:lnRef idx="1">
+            <a:schemeClr val="accent1"/>
+          </a:lnRef>
+          <a:fillRef idx="0">
+            <a:schemeClr val="accent1"/>
+          </a:fillRef>
+          <a:effectRef idx="0">
+            <a:schemeClr val="accent1"/>
+          </a:effectRef>
+          <a:fontRef idx="minor">
+            <a:schemeClr val="tx1"/>
+          </a:fontRef>
+        </p:style>
+      </p:cxnSp>
+      <p:cxnSp>
+        <p:nvCxnSpPr>
+          <p:cNvPr id="91" name="Connector: Elbow 90">
+            <a:extLst>
+              <a:ext uri="{FF2B5EF4-FFF2-40B4-BE49-F238E27FC236}">
+                <a16:creationId xmlns:a16="http://schemas.microsoft.com/office/drawing/2014/main" id="{C2CD8460-CD07-A87E-1BC3-F592C16B56C5}"/>
+              </a:ext>
+            </a:extLst>
+          </p:cNvPr>
+          <p:cNvCxnSpPr>
+            <a:cxnSpLocks/>
+            <a:stCxn id="65" idx="3"/>
+            <a:endCxn id="71" idx="1"/>
+          </p:cNvCxnSpPr>
+          <p:nvPr/>
+        </p:nvCxnSpPr>
+        <p:spPr>
+          <a:xfrm flipH="1">
+            <a:off x="3343275" y="4227051"/>
+            <a:ext cx="8005080" cy="1884096"/>
+          </a:xfrm>
+          <a:prstGeom prst="bentConnector5">
+            <a:avLst>
+              <a:gd name="adj1" fmla="val -2856"/>
+              <a:gd name="adj2" fmla="val 59100"/>
+              <a:gd name="adj3" fmla="val 102856"/>
+            </a:avLst>
+          </a:prstGeom>
+          <a:ln>
+            <a:solidFill>
+              <a:srgbClr val="64D5D2"/>
+            </a:solidFill>
+            <a:tailEnd type="triangle"/>
+          </a:ln>
+        </p:spPr>
+        <p:style>
+          <a:lnRef idx="1">
+            <a:schemeClr val="accent1"/>
+          </a:lnRef>
+          <a:fillRef idx="0">
+            <a:schemeClr val="accent1"/>
+          </a:fillRef>
+          <a:effectRef idx="0">
+            <a:schemeClr val="accent1"/>
+          </a:effectRef>
+          <a:fontRef idx="minor">
+            <a:schemeClr val="tx1"/>
+          </a:fontRef>
+        </p:style>
+      </p:cxnSp>
+    </p:spTree>
+    <p:extLst>
+      <p:ext uri="{BB962C8B-B14F-4D97-AF65-F5344CB8AC3E}">
+        <p14:creationId xmlns:p14="http://schemas.microsoft.com/office/powerpoint/2010/main" val="2229415454"/>
+      </p:ext>
+    </p:extLst>
+  </p:cSld>
+  <p:clrMapOvr>
+    <a:masterClrMapping/>
+  </p:clrMapOvr>
+</p:sld>
+</file>
+
+<file path=ppt/slides/slide5.xml><?xml version="1.0" encoding="utf-8"?>
+<p:sld xmlns:a="http://schemas.openxmlformats.org/drawingml/2006/main" xmlns:r="http://schemas.openxmlformats.org/officeDocument/2006/relationships" xmlns:p="http://schemas.openxmlformats.org/presentationml/2006/main">
+  <p:cSld>
     <p:spTree>
       <p:nvGrpSpPr>
         <p:cNvPr id="1" name=""/>

</xml_diff>